<commit_message>
Add new presentation and research report files for hyperspectral analysis
</commit_message>
<xml_diff>
--- a/model/Presentation_Hyperspectral_Forest.pptx
+++ b/model/Presentation_Hyperspectral_Forest.pptx
@@ -311,7 +311,7 @@
           <a:p>
             <a:fld id="{5BCAD085-E8A6-8845-BD4E-CB4CCA059FC4}" type="datetimeFigureOut">
               <a:rPr lang="en-US" smtClean="0"/>
-              <a:t>6/18/2026</a:t>
+              <a:t>6/18/26</a:t>
             </a:fld>
             <a:endParaRPr lang="en-US"/>
           </a:p>
@@ -479,7 +479,7 @@
           <a:p>
             <a:fld id="{5BCAD085-E8A6-8845-BD4E-CB4CCA059FC4}" type="datetimeFigureOut">
               <a:rPr lang="en-US" smtClean="0"/>
-              <a:t>6/18/2026</a:t>
+              <a:t>6/18/26</a:t>
             </a:fld>
             <a:endParaRPr lang="en-US"/>
           </a:p>
@@ -657,7 +657,7 @@
           <a:p>
             <a:fld id="{5BCAD085-E8A6-8845-BD4E-CB4CCA059FC4}" type="datetimeFigureOut">
               <a:rPr lang="en-US" smtClean="0"/>
-              <a:t>6/18/2026</a:t>
+              <a:t>6/18/26</a:t>
             </a:fld>
             <a:endParaRPr lang="en-US"/>
           </a:p>
@@ -825,7 +825,7 @@
           <a:p>
             <a:fld id="{5BCAD085-E8A6-8845-BD4E-CB4CCA059FC4}" type="datetimeFigureOut">
               <a:rPr lang="en-US" smtClean="0"/>
-              <a:t>6/18/2026</a:t>
+              <a:t>6/18/26</a:t>
             </a:fld>
             <a:endParaRPr lang="en-US"/>
           </a:p>
@@ -1070,7 +1070,7 @@
           <a:p>
             <a:fld id="{5BCAD085-E8A6-8845-BD4E-CB4CCA059FC4}" type="datetimeFigureOut">
               <a:rPr lang="en-US" smtClean="0"/>
-              <a:t>6/18/2026</a:t>
+              <a:t>6/18/26</a:t>
             </a:fld>
             <a:endParaRPr lang="en-US"/>
           </a:p>
@@ -1355,7 +1355,7 @@
           <a:p>
             <a:fld id="{5BCAD085-E8A6-8845-BD4E-CB4CCA059FC4}" type="datetimeFigureOut">
               <a:rPr lang="en-US" smtClean="0"/>
-              <a:t>6/18/2026</a:t>
+              <a:t>6/18/26</a:t>
             </a:fld>
             <a:endParaRPr lang="en-US"/>
           </a:p>
@@ -1774,7 +1774,7 @@
           <a:p>
             <a:fld id="{5BCAD085-E8A6-8845-BD4E-CB4CCA059FC4}" type="datetimeFigureOut">
               <a:rPr lang="en-US" smtClean="0"/>
-              <a:t>6/18/2026</a:t>
+              <a:t>6/18/26</a:t>
             </a:fld>
             <a:endParaRPr lang="en-US"/>
           </a:p>
@@ -1891,7 +1891,7 @@
           <a:p>
             <a:fld id="{5BCAD085-E8A6-8845-BD4E-CB4CCA059FC4}" type="datetimeFigureOut">
               <a:rPr lang="en-US" smtClean="0"/>
-              <a:t>6/18/2026</a:t>
+              <a:t>6/18/26</a:t>
             </a:fld>
             <a:endParaRPr lang="en-US"/>
           </a:p>
@@ -1986,7 +1986,7 @@
           <a:p>
             <a:fld id="{5BCAD085-E8A6-8845-BD4E-CB4CCA059FC4}" type="datetimeFigureOut">
               <a:rPr lang="en-US" smtClean="0"/>
-              <a:t>6/18/2026</a:t>
+              <a:t>6/18/26</a:t>
             </a:fld>
             <a:endParaRPr lang="en-US"/>
           </a:p>
@@ -2261,7 +2261,7 @@
           <a:p>
             <a:fld id="{5BCAD085-E8A6-8845-BD4E-CB4CCA059FC4}" type="datetimeFigureOut">
               <a:rPr lang="en-US" smtClean="0"/>
-              <a:t>6/18/2026</a:t>
+              <a:t>6/18/26</a:t>
             </a:fld>
             <a:endParaRPr lang="en-US"/>
           </a:p>
@@ -2513,7 +2513,7 @@
           <a:p>
             <a:fld id="{5BCAD085-E8A6-8845-BD4E-CB4CCA059FC4}" type="datetimeFigureOut">
               <a:rPr lang="en-US" smtClean="0"/>
-              <a:t>6/18/2026</a:t>
+              <a:t>6/18/26</a:t>
             </a:fld>
             <a:endParaRPr lang="en-US"/>
           </a:p>
@@ -2724,7 +2724,7 @@
           <a:p>
             <a:fld id="{5BCAD085-E8A6-8845-BD4E-CB4CCA059FC4}" type="datetimeFigureOut">
               <a:rPr lang="en-US" smtClean="0"/>
-              <a:t>6/18/2026</a:t>
+              <a:t>6/18/26</a:t>
             </a:fld>
             <a:endParaRPr lang="en-US"/>
           </a:p>

</xml_diff>